<commit_message>
Rewrite engine docs to match live engine; reframe slides to net value-add; polish
</commit_message>
<xml_diff>
--- a/report/Vise_Presentation_Slides.pptx
+++ b/report/Vise_Presentation_Slides.pptx
@@ -13922,7 +13922,7 @@
                 <a:cs typeface="Calibri"/>
                 <a:sym typeface="Calibri"/>
               </a:rPr>
-              <a:t>Bhagya Puppala · Jack Feen </a:t>
+              <a:t>Bhagya Puppala · Jack Feen</a:t>
             </a:r>
             <a:r>
               <a:rPr lang="en-US" sz="1850" b="1" i="0" u="none" strike="noStrike" cap="none">
@@ -13934,7 +13934,7 @@
                 <a:cs typeface="Calibri"/>
                 <a:sym typeface="Calibri"/>
               </a:rPr>
-              <a:t> · </a:t>
+              <a:t> ·</a:t>
             </a:r>
             <a:r>
               <a:rPr lang="en-US" sz="1850" b="1">
@@ -13958,7 +13958,7 @@
                 <a:cs typeface="Calibri"/>
                 <a:sym typeface="Calibri"/>
               </a:rPr>
-              <a:t>   </a:t>
+              <a:t/>
             </a:r>
             <a:endParaRPr sz="1850" b="1" i="0" u="none" strike="noStrike" cap="none">
               <a:solidFill>
@@ -14007,7 +14007,7 @@
                 <a:cs typeface="Calibri"/>
                 <a:sym typeface="Calibri"/>
               </a:rPr>
-              <a:t> · </a:t>
+              <a:t> ·</a:t>
             </a:r>
             <a:r>
               <a:rPr lang="en-US" sz="1850" b="1">
@@ -14019,7 +14019,7 @@
                 <a:cs typeface="Calibri"/>
                 <a:sym typeface="Calibri"/>
               </a:rPr>
-              <a:t> Nisha Sapkota ·  Rio Yokoyama  </a:t>
+              <a:t> Nisha Sapkota · Rio Yokoyama</a:t>
             </a:r>
             <a:endParaRPr sz="1850" b="1" i="0" u="none" strike="noStrike" cap="none">
               <a:solidFill>
@@ -14424,7 +14424,7 @@
                 <a:cs typeface="Calibri"/>
                 <a:sym typeface="Calibri"/>
               </a:rPr>
-              <a:t> Quantified tax alpha across bear, baseline, and bull regimes, confirming measurable after-tax benefits even after liquidation drag.</a:t>
+              <a:t> Quantified the net value-add of harvesting across bear, baseline, and bull regimes, decomposing it into tax saved versus replacement-ETF tracking.</a:t>
             </a:r>
             <a:endParaRPr sz="1700" dirty="0">
               <a:solidFill>
@@ -14552,7 +14552,7 @@
                 <a:cs typeface="Calibri"/>
                 <a:sym typeface="Calibri"/>
               </a:rPr>
-              <a:t> Models the full trade lifecycle including dividends, lot-level TLH, proxy swaps, execution costs, liquidation for realistic results. </a:t>
+              <a:t> Models the full trade lifecycle including dividends (optional), lot-level TLH, proxy swaps, execution costs, liquidation for realistic results. </a:t>
             </a:r>
             <a:endParaRPr sz="1700" dirty="0">
               <a:solidFill>
@@ -17484,7 +17484,7 @@
                 <a:cs typeface="Calibri"/>
                 <a:sym typeface="Calibri"/>
               </a:rPr>
-              <a:t>The additional return earned purely through tax-efficient moves like TLH, return generated not by picking better stocks, but by paying less tax.</a:t>
+              <a:t>The net value-add of harvesting versus an identical no-TLH portfolio. It combines tax saved, the tracking of the replacement ETF you must hold, and trading cost, and in our results is usually dominated by tracking rather than tax.</a:t>
             </a:r>
             <a:endParaRPr sz="1080" b="1" i="0" u="none" strike="noStrike" cap="none">
               <a:solidFill>
@@ -17861,7 +17861,7 @@
                 <a:cs typeface="Calibri"/>
                 <a:sym typeface="Calibri"/>
               </a:rPr>
-              <a:t>trade offs</a:t>
+              <a:t>trade-offs</a:t>
             </a:r>
             <a:r>
               <a:rPr lang="en-US" sz="1550" b="0" i="1" u="none" strike="noStrike" cap="none">
@@ -27852,7 +27852,7 @@
                 <a:cs typeface="Calibri"/>
                 <a:sym typeface="Calibri"/>
               </a:rPr>
-              <a:t>TLH Alpha</a:t>
+              <a:t>Net Value-Add</a:t>
             </a:r>
             <a:endParaRPr sz="1300" b="0">
               <a:solidFill>
@@ -47563,7 +47563,7 @@
                 <a:cs typeface="Calibri"/>
                 <a:sym typeface="Calibri"/>
               </a:rPr>
-              <a:t>Rank 1 = highest avg Tax Alpha across all portfolios  |  TLH threshold = 10%  |  $1M initial capital  |  35% ST / 20% LT tax rates</a:t>
+              <a:t>Rank 1 = highest avg net value-add across all portfolios  |  TLH threshold = 10%  |  $1M initial capital  |  35% ST / 20% LT tax rates</a:t>
             </a:r>
             <a:endParaRPr>
               <a:solidFill>
@@ -48613,7 +48613,7 @@
                           <a:cs typeface="Calibri"/>
                           <a:sym typeface="Calibri"/>
                         </a:rPr>
-                        <a:t>Pre-Liq Tax Alpha</a:t>
+                        <a:t>Pre-Liq Net Value-Add</a:t>
                       </a:r>
                       <a:endParaRPr sz="1300"/>
                     </a:p>
@@ -48684,7 +48684,7 @@
                           <a:cs typeface="Calibri"/>
                           <a:sym typeface="Calibri"/>
                         </a:rPr>
-                        <a:t>Post-Liq Tax Alpha</a:t>
+                        <a:t>Post-Liq Net Value-Add</a:t>
                       </a:r>
                       <a:endParaRPr sz="1300"/>
                     </a:p>
@@ -50079,7 +50079,7 @@
                 <a:cs typeface="Calibri"/>
                 <a:sym typeface="Calibri"/>
               </a:rPr>
-              <a:t>• Pre-Liq Tax Alpha ($): </a:t>
+              <a:t>• Pre-Liq Net Value-Add ($): </a:t>
             </a:r>
             <a:r>
               <a:rPr lang="en-US" sz="1200">
@@ -50091,7 +50091,7 @@
                 <a:cs typeface="Calibri"/>
                 <a:sym typeface="Calibri"/>
               </a:rPr>
-              <a:t>TLH NAV − No-TLH NAV while the portfolio remains invested; reflects the compounding benefit of tax deferral </a:t>
+              <a:t>TLH NAV − No-TLH NAV while the portfolio remains invested; reflects tax saved plus how the replacement ETFs tracked while invested (usually tracking-dominated) </a:t>
             </a:r>
             <a:endParaRPr sz="1200">
               <a:solidFill>
@@ -50123,7 +50123,7 @@
                 <a:cs typeface="Calibri"/>
                 <a:sym typeface="Calibri"/>
               </a:rPr>
-              <a:t>• Post-Liq Tax Alpha ($): </a:t>
+              <a:t>• Post-Liq Net Value-Add ($): </a:t>
             </a:r>
             <a:r>
               <a:rPr lang="en-US" sz="1200">
@@ -50485,7 +50485,7 @@
                 <a:cs typeface="Calibri"/>
                 <a:sym typeface="Calibri"/>
               </a:rPr>
-              <a:t>Tax alphas for the best-performing rebalancing strategy in each market regime  |  $1M initial capital</a:t>
+              <a:t>Net value-add for the best-performing rebalancing strategy in each market regime  |  $1M initial capital</a:t>
             </a:r>
             <a:endParaRPr>
               <a:solidFill>

</xml_diff>